<commit_message>
Protótipo navegável das telas do conector
Front-end em Angular 21 com as três telas que sustentam a tese do produto:

- Conexões: ERPs de origem (MV, Tasy, laboratório) e uma planilha legada,
  com sincronização que alimenta a fila de identificação
- Identificação: pares de registros candidatos a serem o mesmo paciente,
  com score, comparação campo a campo e recomendação — incluindo um caso
  de homônimo em que a recomendação é não costurar
- Histórico unificado: linha do tempo única com a origem de cada evento e
  alternador entre a visão fragmentada de hoje e a visão costurada

Sem backend: o estado vive em memória em core/sutura-store.ts, que é o
ponto de troca pelas chamadas ao Spring Boot na próxima fase.

Inclui o material da mentoria em docs/apresentacao (roteiro cronometrado e
capturas das telas) e atualiza o slide de fases do deck, que ainda indicava
estágio de descoberta.
</commit_message>
<xml_diff>
--- a/docs/Rich-Picture-Mapa-Stakeholders-Tela-Sutura.pptx
+++ b/docs/Rich-Picture-Mapa-Stakeholders-Tela-Sutura.pptx
@@ -12103,8 +12103,8 @@
         </p:nvSpPr>
         <p:spPr>
           <a:xfrm>
-            <a:off x="15919152" y="636075"/>
-            <a:ext cx="1797348" cy="356526"/>
+            <a:off x="14936500" y="636075"/>
+            <a:ext cx="2780000" cy="356526"/>
           </a:xfrm>
           <a:prstGeom prst="roundRect">
             <a:avLst>
@@ -12130,8 +12130,8 @@
         </p:nvSpPr>
         <p:spPr>
           <a:xfrm>
-            <a:off x="16057793" y="727092"/>
-            <a:ext cx="1596264" cy="212593"/>
+            <a:off x="15075141" y="727092"/>
+            <a:ext cx="2500000" cy="212593"/>
           </a:xfrm>
           <a:prstGeom prst="rect">
             <a:avLst/>
@@ -12157,7 +12157,7 @@
                 <a:ea typeface="Courier New" pitchFamily="34" charset="-122"/>
                 <a:cs typeface="Courier New" pitchFamily="34" charset="-120"/>
               </a:rPr>
-              <a:t>Estágio: descoberta</a:t>
+              <a:t>Estágio: MVP em desenvolvimento</a:t>
             </a:r>
             <a:endParaRPr lang="en-US" sz="1050" dirty="0"/>
           </a:p>
@@ -13221,16 +13221,14 @@
             </a:avLst>
           </a:prstGeom>
           <a:solidFill>
-            <a:srgbClr val="2C6BC4"/>
-          </a:solidFill>
-          <a:ln/>
-          <a:effectLst>
-            <a:outerShdw sx="100000" sy="100000" kx="0" ky="0" algn="bl" rotWithShape="0" blurRad="190500" dist="76200" dir="5400000">
-              <a:srgbClr val="2C6BC4">
-                <a:alpha val="25000"/>
-              </a:srgbClr>
-            </a:outerShdw>
-          </a:effectLst>
+            <a:srgbClr val="EEF3F9"/>
+          </a:solidFill>
+          <a:ln w="5292">
+            <a:solidFill>
+              <a:srgbClr val="CBD8E8"/>
+            </a:solidFill>
+            <a:prstDash val="solid"/>
+          </a:ln>
         </p:spPr>
       </p:sp>
       <p:sp>
@@ -13262,15 +13260,13 @@
             <a:r>
               <a:rPr lang="en-US" sz="863" spc="38" kern="0" dirty="0">
                 <a:solidFill>
-                  <a:srgbClr val="FFFFFF">
-                    <a:alpha val="90000"/>
-                  </a:srgbClr>
+                  <a:srgbClr val="7A8696"/>
                 </a:solidFill>
                 <a:latin typeface="Courier New" pitchFamily="34" charset="0"/>
                 <a:ea typeface="Courier New" pitchFamily="34" charset="-122"/>
                 <a:cs typeface="Courier New" pitchFamily="34" charset="-120"/>
               </a:rPr>
-              <a:t>● FASE ATUAL</a:t>
+              <a:t>CONCLUÍDA</a:t>
             </a:r>
             <a:endParaRPr lang="en-US" sz="863" dirty="0"/>
           </a:p>
@@ -13308,7 +13304,7 @@
             <a:r>
               <a:rPr lang="en-US" sz="2250" b="1" dirty="0">
                 <a:solidFill>
-                  <a:srgbClr val="FFFFFF"/>
+                  <a:srgbClr val="7A8696"/>
                 </a:solidFill>
                 <a:latin typeface="Arial" pitchFamily="34" charset="0"/>
                 <a:ea typeface="Arial" pitchFamily="34" charset="-122"/>
@@ -13352,7 +13348,7 @@
             <a:r>
               <a:rPr lang="en-US" sz="1200" dirty="0">
                 <a:solidFill>
-                  <a:srgbClr val="FFFFFF"/>
+                  <a:srgbClr val="5A6675"/>
                 </a:solidFill>
                 <a:latin typeface="Arial" pitchFamily="34" charset="0"/>
                 <a:ea typeface="Arial" pitchFamily="34" charset="-122"/>
@@ -13411,14 +13407,16 @@
             </a:avLst>
           </a:prstGeom>
           <a:solidFill>
-            <a:srgbClr val="EEF3F9"/>
-          </a:solidFill>
-          <a:ln w="5292">
-            <a:solidFill>
-              <a:srgbClr val="CBD8E8"/>
-            </a:solidFill>
-            <a:prstDash val="solid"/>
-          </a:ln>
+            <a:srgbClr val="2C6BC4"/>
+          </a:solidFill>
+          <a:ln/>
+          <a:effectLst>
+            <a:outerShdw sx="100000" sy="100000" kx="0" ky="0" algn="bl" rotWithShape="0" blurRad="190500" dist="76200" dir="5400000">
+              <a:srgbClr val="2C6BC4">
+                <a:alpha val="25000"/>
+              </a:srgbClr>
+            </a:outerShdw>
+          </a:effectLst>
         </p:spPr>
       </p:sp>
       <p:sp>
@@ -13450,13 +13448,15 @@
             <a:r>
               <a:rPr lang="en-US" sz="863" spc="38" kern="0" dirty="0">
                 <a:solidFill>
-                  <a:srgbClr val="22538F"/>
+                  <a:srgbClr val="FFFFFF">
+                    <a:alpha val="90000"/>
+                  </a:srgbClr>
                 </a:solidFill>
                 <a:latin typeface="Courier New" pitchFamily="34" charset="0"/>
                 <a:ea typeface="Courier New" pitchFamily="34" charset="-122"/>
                 <a:cs typeface="Courier New" pitchFamily="34" charset="-120"/>
               </a:rPr>
-              <a:t>PRÓXIMA</a:t>
+              <a:t>● FASE ATUAL</a:t>
             </a:r>
             <a:endParaRPr lang="en-US" sz="863" dirty="0"/>
           </a:p>
@@ -13494,7 +13494,7 @@
             <a:r>
               <a:rPr lang="en-US" sz="2250" b="1" dirty="0">
                 <a:solidFill>
-                  <a:srgbClr val="22538F"/>
+                  <a:srgbClr val="FFFFFF"/>
                 </a:solidFill>
                 <a:latin typeface="Arial" pitchFamily="34" charset="0"/>
                 <a:ea typeface="Arial" pitchFamily="34" charset="-122"/>
@@ -13538,7 +13538,7 @@
             <a:r>
               <a:rPr lang="en-US" sz="1200" dirty="0">
                 <a:solidFill>
-                  <a:srgbClr val="3C4654"/>
+                  <a:srgbClr val="FFFFFF"/>
                 </a:solidFill>
                 <a:latin typeface="Arial" pitchFamily="34" charset="0"/>
                 <a:ea typeface="Arial" pitchFamily="34" charset="-122"/>
@@ -13555,7 +13555,7 @@
             <a:r>
               <a:rPr lang="en-US" sz="1200" b="1" dirty="0">
                 <a:solidFill>
-                  <a:srgbClr val="3C4654"/>
+                  <a:srgbClr val="FFFFFF"/>
                 </a:solidFill>
                 <a:latin typeface="Arial" pitchFamily="34" charset="0"/>
                 <a:ea typeface="Arial" pitchFamily="34" charset="-122"/>
@@ -13659,7 +13659,7 @@
                 <a:ea typeface="Courier New" pitchFamily="34" charset="-122"/>
                 <a:cs typeface="Courier New" pitchFamily="34" charset="-120"/>
               </a:rPr>
-              <a:t>DEPOIS</a:t>
+              <a:t>PRÓXIMA</a:t>
             </a:r>
             <a:endParaRPr lang="en-US" sz="863" dirty="0"/>
           </a:p>

</xml_diff>